<commit_message>
feat: web page and docker setup, footers in the bottom strip of every layout
</commit_message>
<xml_diff>
--- a/src/outline2pptx/templates/clean.pptx
+++ b/src/outline2pptx/templates/clean.pptx
@@ -198,8 +198,8 @@
         </p:nvSpPr>
         <p:spPr>
           <a:xfrm>
-            <a:off x="812800" y="0"/>
-            <a:ext cx="3793066" cy="0"/>
+            <a:off x="640080" y="6200000"/>
+            <a:ext cx="3500000" cy="400050"/>
           </a:xfrm>
         </p:spPr>
         <p:txBody>
@@ -226,8 +226,8 @@
         </p:nvSpPr>
         <p:spPr>
           <a:xfrm>
-            <a:off x="5554133" y="0"/>
-            <a:ext cx="5147733" cy="0"/>
+            <a:off x="4346000" y="6200000"/>
+            <a:ext cx="3500000" cy="400050"/>
           </a:xfrm>
         </p:spPr>
         <p:txBody>
@@ -250,8 +250,8 @@
         </p:nvSpPr>
         <p:spPr>
           <a:xfrm>
-            <a:off x="11650133" y="0"/>
-            <a:ext cx="3793066" cy="0"/>
+            <a:off x="8051920" y="6200000"/>
+            <a:ext cx="3500000" cy="400050"/>
           </a:xfrm>
         </p:spPr>
         <p:txBody>
@@ -401,8 +401,8 @@
         </p:nvSpPr>
         <p:spPr>
           <a:xfrm>
-            <a:off x="812800" y="0"/>
-            <a:ext cx="3793066" cy="0"/>
+            <a:off x="640080" y="6200000"/>
+            <a:ext cx="3500000" cy="400050"/>
           </a:xfrm>
         </p:spPr>
         <p:txBody>
@@ -429,8 +429,8 @@
         </p:nvSpPr>
         <p:spPr>
           <a:xfrm>
-            <a:off x="5554133" y="0"/>
-            <a:ext cx="5147733" cy="0"/>
+            <a:off x="4346000" y="6200000"/>
+            <a:ext cx="3500000" cy="400050"/>
           </a:xfrm>
         </p:spPr>
         <p:txBody>
@@ -453,8 +453,8 @@
         </p:nvSpPr>
         <p:spPr>
           <a:xfrm>
-            <a:off x="11650133" y="0"/>
-            <a:ext cx="3793066" cy="0"/>
+            <a:off x="8051920" y="6200000"/>
+            <a:ext cx="3500000" cy="400050"/>
           </a:xfrm>
         </p:spPr>
         <p:txBody>
@@ -604,8 +604,8 @@
         </p:nvSpPr>
         <p:spPr>
           <a:xfrm>
-            <a:off x="812800" y="0"/>
-            <a:ext cx="3793066" cy="0"/>
+            <a:off x="640080" y="6200000"/>
+            <a:ext cx="3500000" cy="400050"/>
           </a:xfrm>
         </p:spPr>
         <p:txBody>
@@ -632,8 +632,8 @@
         </p:nvSpPr>
         <p:spPr>
           <a:xfrm>
-            <a:off x="5554133" y="0"/>
-            <a:ext cx="5147733" cy="0"/>
+            <a:off x="4346000" y="6200000"/>
+            <a:ext cx="3500000" cy="400050"/>
           </a:xfrm>
         </p:spPr>
         <p:txBody>
@@ -656,8 +656,8 @@
         </p:nvSpPr>
         <p:spPr>
           <a:xfrm>
-            <a:off x="11650133" y="0"/>
-            <a:ext cx="3793066" cy="0"/>
+            <a:off x="8051920" y="6200000"/>
+            <a:ext cx="3500000" cy="400050"/>
           </a:xfrm>
         </p:spPr>
         <p:txBody>
@@ -746,8 +746,8 @@
         </p:nvSpPr>
         <p:spPr>
           <a:xfrm>
-            <a:off x="812800" y="0"/>
-            <a:ext cx="3793066" cy="0"/>
+            <a:off x="640080" y="6200000"/>
+            <a:ext cx="3500000" cy="400050"/>
           </a:xfrm>
         </p:spPr>
         <p:txBody>
@@ -774,8 +774,8 @@
         </p:nvSpPr>
         <p:spPr>
           <a:xfrm>
-            <a:off x="5554133" y="0"/>
-            <a:ext cx="5147733" cy="0"/>
+            <a:off x="4346000" y="6200000"/>
+            <a:ext cx="3500000" cy="400050"/>
           </a:xfrm>
         </p:spPr>
         <p:txBody>
@@ -798,8 +798,8 @@
         </p:nvSpPr>
         <p:spPr>
           <a:xfrm>
-            <a:off x="11650133" y="0"/>
-            <a:ext cx="3793066" cy="0"/>
+            <a:off x="8051920" y="6200000"/>
+            <a:ext cx="3500000" cy="400050"/>
           </a:xfrm>
         </p:spPr>
         <p:txBody>
@@ -1010,8 +1010,8 @@
         </p:nvSpPr>
         <p:spPr>
           <a:xfrm>
-            <a:off x="812800" y="0"/>
-            <a:ext cx="3793066" cy="0"/>
+            <a:off x="640080" y="6200000"/>
+            <a:ext cx="3500000" cy="400050"/>
           </a:xfrm>
         </p:spPr>
         <p:txBody>
@@ -1038,8 +1038,8 @@
         </p:nvSpPr>
         <p:spPr>
           <a:xfrm>
-            <a:off x="5554133" y="0"/>
-            <a:ext cx="5147733" cy="0"/>
+            <a:off x="4346000" y="6200000"/>
+            <a:ext cx="3500000" cy="400050"/>
           </a:xfrm>
         </p:spPr>
         <p:txBody>
@@ -1062,8 +1062,8 @@
         </p:nvSpPr>
         <p:spPr>
           <a:xfrm>
-            <a:off x="11650133" y="0"/>
-            <a:ext cx="3793066" cy="0"/>
+            <a:off x="8051920" y="6200000"/>
+            <a:ext cx="3500000" cy="400050"/>
           </a:xfrm>
         </p:spPr>
         <p:txBody>
@@ -1338,8 +1338,8 @@
         </p:nvSpPr>
         <p:spPr>
           <a:xfrm>
-            <a:off x="812800" y="0"/>
-            <a:ext cx="3793066" cy="0"/>
+            <a:off x="640080" y="6200000"/>
+            <a:ext cx="3500000" cy="400050"/>
           </a:xfrm>
         </p:spPr>
         <p:txBody>
@@ -1366,8 +1366,8 @@
         </p:nvSpPr>
         <p:spPr>
           <a:xfrm>
-            <a:off x="5554133" y="0"/>
-            <a:ext cx="5147733" cy="0"/>
+            <a:off x="4346000" y="6200000"/>
+            <a:ext cx="3500000" cy="400050"/>
           </a:xfrm>
         </p:spPr>
         <p:txBody>
@@ -1390,8 +1390,8 @@
         </p:nvSpPr>
         <p:spPr>
           <a:xfrm>
-            <a:off x="11650133" y="0"/>
-            <a:ext cx="3793066" cy="0"/>
+            <a:off x="8051920" y="6200000"/>
+            <a:ext cx="3500000" cy="400050"/>
           </a:xfrm>
         </p:spPr>
         <p:txBody>
@@ -1480,8 +1480,8 @@
         </p:nvSpPr>
         <p:spPr>
           <a:xfrm>
-            <a:off x="812800" y="0"/>
-            <a:ext cx="3793066" cy="0"/>
+            <a:off x="640080" y="6200000"/>
+            <a:ext cx="3500000" cy="400050"/>
           </a:xfrm>
         </p:spPr>
         <p:txBody>
@@ -1508,8 +1508,8 @@
         </p:nvSpPr>
         <p:spPr>
           <a:xfrm>
-            <a:off x="5554133" y="0"/>
-            <a:ext cx="5147733" cy="0"/>
+            <a:off x="4346000" y="6200000"/>
+            <a:ext cx="3500000" cy="400050"/>
           </a:xfrm>
         </p:spPr>
         <p:txBody>
@@ -1532,8 +1532,8 @@
         </p:nvSpPr>
         <p:spPr>
           <a:xfrm>
-            <a:off x="11650133" y="0"/>
-            <a:ext cx="3793066" cy="0"/>
+            <a:off x="8051920" y="6200000"/>
+            <a:ext cx="3500000" cy="400050"/>
           </a:xfrm>
         </p:spPr>
         <p:txBody>
@@ -1683,8 +1683,8 @@
         </p:nvSpPr>
         <p:spPr>
           <a:xfrm>
-            <a:off x="812800" y="0"/>
-            <a:ext cx="3793066" cy="0"/>
+            <a:off x="640080" y="6200000"/>
+            <a:ext cx="3500000" cy="400050"/>
           </a:xfrm>
         </p:spPr>
         <p:txBody>
@@ -1711,8 +1711,8 @@
         </p:nvSpPr>
         <p:spPr>
           <a:xfrm>
-            <a:off x="5554133" y="0"/>
-            <a:ext cx="5147733" cy="0"/>
+            <a:off x="4346000" y="6200000"/>
+            <a:ext cx="3500000" cy="400050"/>
           </a:xfrm>
         </p:spPr>
         <p:txBody>
@@ -1735,8 +1735,8 @@
         </p:nvSpPr>
         <p:spPr>
           <a:xfrm>
-            <a:off x="11650133" y="0"/>
-            <a:ext cx="3793066" cy="0"/>
+            <a:off x="8051920" y="6200000"/>
+            <a:ext cx="3500000" cy="400050"/>
           </a:xfrm>
         </p:spPr>
         <p:txBody>
@@ -1918,8 +1918,8 @@
         </p:nvSpPr>
         <p:spPr>
           <a:xfrm>
-            <a:off x="812800" y="0"/>
-            <a:ext cx="3793066" cy="0"/>
+            <a:off x="640080" y="6200000"/>
+            <a:ext cx="3500000" cy="400050"/>
           </a:xfrm>
         </p:spPr>
         <p:txBody>
@@ -1946,8 +1946,8 @@
         </p:nvSpPr>
         <p:spPr>
           <a:xfrm>
-            <a:off x="5554133" y="0"/>
-            <a:ext cx="5147733" cy="0"/>
+            <a:off x="4346000" y="6200000"/>
+            <a:ext cx="3500000" cy="400050"/>
           </a:xfrm>
         </p:spPr>
         <p:txBody>
@@ -1970,8 +1970,8 @@
         </p:nvSpPr>
         <p:spPr>
           <a:xfrm>
-            <a:off x="11650133" y="0"/>
-            <a:ext cx="3793066" cy="0"/>
+            <a:off x="8051920" y="6200000"/>
+            <a:ext cx="3500000" cy="400050"/>
           </a:xfrm>
         </p:spPr>
         <p:txBody>
@@ -2128,8 +2128,8 @@
         </p:nvSpPr>
         <p:spPr>
           <a:xfrm>
-            <a:off x="609600" y="6356350"/>
-            <a:ext cx="2844800" cy="365125"/>
+            <a:off x="640080" y="6200000"/>
+            <a:ext cx="3500000" cy="400050"/>
           </a:xfrm>
           <a:prstGeom prst="rect">
             <a:avLst/>
@@ -2169,8 +2169,8 @@
         </p:nvSpPr>
         <p:spPr>
           <a:xfrm>
-            <a:off x="4165600" y="6356350"/>
-            <a:ext cx="3860800" cy="365125"/>
+            <a:off x="4346000" y="6200000"/>
+            <a:ext cx="3500000" cy="400050"/>
           </a:xfrm>
           <a:prstGeom prst="rect">
             <a:avLst/>
@@ -2206,8 +2206,8 @@
         </p:nvSpPr>
         <p:spPr>
           <a:xfrm>
-            <a:off x="8737600" y="6356350"/>
-            <a:ext cx="2844800" cy="365125"/>
+            <a:off x="8051920" y="6200000"/>
+            <a:ext cx="3500000" cy="400050"/>
           </a:xfrm>
           <a:prstGeom prst="rect">
             <a:avLst/>

</xml_diff>

<commit_message>
fix: no bullet in front of a one line placeholder, and Poppins in the image
A resized placeholder lost the stock buNone of its first level, so a bullet dot appeared in
front of the cover subtitle, the closing line and every subheading. The size writer now keeps
the bullet rules of the level it replaces and switches the bullet off for the placeholders
that hold a single line, and all three templates were regenerated.

The image installs the bundled Poppins faces, so LibreOffice renders what the measurement
was made with instead of substituting another font.

Two tests read the effective bullet of a placeholder, walking from the paragraph to the
layout to the master, rather than the attribute the generator wrote.
</commit_message>
<xml_diff>
--- a/src/outline2pptx/templates/clean.pptx
+++ b/src/outline2pptx/templates/clean.pptx
@@ -141,7 +141,8 @@
         <p:txBody>
           <a:bodyPr/>
           <a:lstStyle>
-            <a:lvl1pPr>
+            <a:lvl1pPr marL="0" indent="0">
+              <a:buNone/>
               <a:defRPr sz="4000"/>
             </a:lvl1pPr>
           </a:lstStyle>
@@ -173,7 +174,8 @@
         <p:txBody>
           <a:bodyPr/>
           <a:lstStyle>
-            <a:lvl1pPr>
+            <a:lvl1pPr marL="0" indent="0">
+              <a:buNone/>
               <a:defRPr sz="2000"/>
             </a:lvl1pPr>
           </a:lstStyle>
@@ -315,7 +317,8 @@
         <p:txBody>
           <a:bodyPr/>
           <a:lstStyle>
-            <a:lvl1pPr>
+            <a:lvl1pPr marL="0" indent="0">
+              <a:buNone/>
               <a:defRPr sz="4000"/>
             </a:lvl1pPr>
           </a:lstStyle>
@@ -347,7 +350,8 @@
         <p:txBody>
           <a:bodyPr/>
           <a:lstStyle>
-            <a:lvl1pPr>
+            <a:lvl1pPr marL="0" indent="0">
+              <a:buNone/>
               <a:defRPr sz="2000"/>
             </a:lvl1pPr>
           </a:lstStyle>
@@ -518,7 +522,8 @@
         <p:txBody>
           <a:bodyPr/>
           <a:lstStyle>
-            <a:lvl1pPr>
+            <a:lvl1pPr marL="0" indent="0">
+              <a:buNone/>
               <a:defRPr sz="3200"/>
             </a:lvl1pPr>
           </a:lstStyle>
@@ -721,7 +726,8 @@
         <p:txBody>
           <a:bodyPr anchor="t"/>
           <a:lstStyle>
-            <a:lvl1pPr>
+            <a:lvl1pPr marL="0" indent="0">
+              <a:buNone/>
               <a:defRPr sz="4000"/>
             </a:lvl1pPr>
           </a:lstStyle>
@@ -863,7 +869,8 @@
         <p:txBody>
           <a:bodyPr/>
           <a:lstStyle>
-            <a:lvl1pPr>
+            <a:lvl1pPr marL="0" indent="0">
+              <a:buNone/>
               <a:defRPr sz="3200"/>
             </a:lvl1pPr>
           </a:lstStyle>
@@ -1127,7 +1134,8 @@
         <p:txBody>
           <a:bodyPr/>
           <a:lstStyle>
-            <a:lvl1pPr>
+            <a:lvl1pPr marL="0" indent="0">
+              <a:buNone/>
               <a:defRPr sz="3200"/>
             </a:lvl1pPr>
           </a:lstStyle>
@@ -1159,7 +1167,8 @@
         <p:txBody>
           <a:bodyPr anchor="b"/>
           <a:lstStyle>
-            <a:lvl1pPr>
+            <a:lvl1pPr marL="0" indent="0">
+              <a:buNone/>
               <a:defRPr sz="2000"/>
             </a:lvl1pPr>
           </a:lstStyle>
@@ -1252,7 +1261,8 @@
         <p:txBody>
           <a:bodyPr anchor="b"/>
           <a:lstStyle>
-            <a:lvl1pPr>
+            <a:lvl1pPr marL="0" indent="0">
+              <a:buNone/>
               <a:defRPr sz="2000"/>
             </a:lvl1pPr>
           </a:lstStyle>
@@ -1455,7 +1465,8 @@
         <p:txBody>
           <a:bodyPr/>
           <a:lstStyle>
-            <a:lvl1pPr>
+            <a:lvl1pPr marL="0" indent="0">
+              <a:buNone/>
               <a:defRPr sz="4000"/>
             </a:lvl1pPr>
           </a:lstStyle>
@@ -1597,7 +1608,8 @@
         <p:txBody>
           <a:bodyPr anchor="b"/>
           <a:lstStyle>
-            <a:lvl1pPr>
+            <a:lvl1pPr marL="0" indent="0">
+              <a:buNone/>
               <a:defRPr sz="3200"/>
             </a:lvl1pPr>
           </a:lstStyle>
@@ -1800,7 +1812,8 @@
         <p:txBody>
           <a:bodyPr anchor="b"/>
           <a:lstStyle>
-            <a:lvl1pPr>
+            <a:lvl1pPr marL="0" indent="0">
+              <a:buNone/>
               <a:defRPr sz="3200"/>
             </a:lvl1pPr>
           </a:lstStyle>
@@ -1893,7 +1906,8 @@
         <p:txBody>
           <a:bodyPr/>
           <a:lstStyle>
-            <a:lvl1pPr>
+            <a:lvl1pPr marL="0" indent="0">
+              <a:buNone/>
               <a:defRPr sz="1800"/>
             </a:lvl1pPr>
           </a:lstStyle>

</xml_diff>